<commit_message>
docs(pitch): match the overview page on fees and dispute splits
The system overview now leads with what each party pays, so the deck
says the same: no fee on refunds or the shipper's share of a dispute
split, and the fee rate is set by admin vote but fixed per shipment.
</commit_message>
<xml_diff>
--- a/docs/pitch/gajufreight-pitch-deck.pptx
+++ b/docs/pitch/gajufreight-pitch-deck.pptx
@@ -1141,7 +1141,7 @@
           <a:lstStyle/>
           <a:p>
             <a:r>
-              <a:t>Network fees are about 0.0002 Gaju per action, so a whole shipment with two legs costs about 0.0044 Gaju in network fees, shared between the parties. Prices and payments are in Gaju (木) for now; other currencies are out of scope for the pilot.</a:t>
+              <a:t>Network fees are about 0.0002 Gaju per action, so a whole shipment with two legs costs about 0.0044 Gaju in network fees, shared between the parties. Prices and payments are in Gaju (木) for now; other currencies are out of scope for the pilot. The fee rate and minimum are set by GajuFreight's admin vote and can change, but a shipment keeps the rate in force when its quotes were requested; the 10% cap is built into the contract.</a:t>
             </a:r>
           </a:p>
         </p:txBody>
@@ -10008,7 +10008,7 @@
                 </a:solidFill>
                 <a:latin typeface="Montserrat"/>
               </a:rPr>
-              <a:t>Pay the agreed price, and nothing more. Refunds carry no fee.</a:t>
+              <a:t>Pay the agreed price, and nothing more. Refunds and your share of a dispute split carry no fee.</a:t>
             </a:r>
           </a:p>
         </p:txBody>

</xml_diff>

<commit_message>
docs(pitch): state the 10% fee limit as the contract enforces it
The owner asked for the fee to read as 1% of the shipping cost with a
1 Gaju minimum, and a 10% ceiling fixed in the contract that no vote
can raise and that overrides the minimum. Checked against fee_due in
shipment-escrow.aes and in_bounds in platform.aes.
</commit_message>
<xml_diff>
--- a/docs/pitch/gajufreight-pitch-deck.pptx
+++ b/docs/pitch/gajufreight-pitch-deck.pptx
@@ -931,7 +931,7 @@
           <a:lstStyle/>
           <a:p>
             <a:r>
-              <a:t>Fee: 1% of payouts, with a minimum of 1 Gaju and never more than 10% of any payout. The rate is fixed when the quote is requested, so it can't change mid-shipment.</a:t>
+              <a:t>Fee: 1% of the shipping cost, taken from payouts, with a minimum of 1 Gaju. The contract never takes more than 10% of the shipping cost, even for a tiny shipment. The rate is fixed when the quote is requested, so it can't change mid-shipment.</a:t>
             </a:r>
           </a:p>
         </p:txBody>
@@ -1141,7 +1141,7 @@
           <a:lstStyle/>
           <a:p>
             <a:r>
-              <a:t>Network fees are about 0.0002 Gaju per action, so a whole shipment with two legs costs about 0.0044 Gaju in network fees, shared between the parties. Prices and payments are in Gaju (木) for now; other currencies are out of scope for the pilot. The fee rate and minimum are set by GajuFreight's admin vote and can change, but a shipment keeps the rate in force when its quotes were requested; the 10% cap is built into the contract.</a:t>
+              <a:t>Network fees are about 0.0002 Gaju per action, so a whole shipment with two legs costs about 0.0044 Gaju in network fees, shared between the parties. Prices and payments are in Gaju (木) for now; other currencies are out of scope for the pilot. The fee starts at 1% with a 1 Gaju minimum; both are set by GajuFreight's admin vote and can change, but a shipment keeps the settings in force when its quotes were requested. The 10% limit is fixed in the contract: no vote can raise the rate above it, and it overrides the minimum.</a:t>
             </a:r>
           </a:p>
         </p:txBody>
@@ -10130,7 +10130,7 @@
                 </a:solidFill>
                 <a:latin typeface="Montserrat"/>
               </a:rPr>
-              <a:t>1% of each payout (minimum 1 Gaju, never more than 10% of a payout), fixed when the quote is requested.</a:t>
+              <a:t>1% of the shipping cost (minimum 1 Gaju), fixed when the quote is requested. Never more than 10%: a limit built into the contract.</a:t>
             </a:r>
           </a:p>
         </p:txBody>

</xml_diff>

<commit_message>
docs(ux): apply review of #158 and update the deck for ADR 0018/0019
Independent pragmatic review of #158: four screens still said the fee
came from payouts; the cancel rule now matches the contract (either
side, any time while unconfirmed); the leg carrier's confirm step and
signature counts are in the journeys; repeated and speculative text is
trimmed; the Q12 caveat is restored; and the expiry is set by the app.
The pitch deck now says the forwarder stakes the fee on confirming and
loses it on failing, adds verified businesses, and uses 0.005 Gaju.
</commit_message>
<xml_diff>
--- a/docs/pitch/gajufreight-pitch-deck.pptx
+++ b/docs/pitch/gajufreight-pitch-deck.pptx
@@ -861,7 +861,7 @@
           <a:lstStyle/>
           <a:p>
             <a:r>
-              <a:t>The shipper pays exactly the agreed price: the platform fee comes out of the forwarder's payouts, and refunds carry no fee.</a:t>
+              <a:t>The shipper pays exactly the agreed price: the forwarder pays the platform fee when it confirms the booking, and refunds carry no fee.</a:t>
             </a:r>
           </a:p>
         </p:txBody>
@@ -931,7 +931,7 @@
           <a:lstStyle/>
           <a:p>
             <a:r>
-              <a:t>Fee: 1% of the shipping cost, taken from payouts, with a minimum of 1 Gaju. The contract never takes more than 10% of the shipping cost, even for a tiny shipment. The rate is fixed when the quote is requested, so it can't change mid-shipment.</a:t>
+              <a:t>Fee: 1% of the shipping cost, with a minimum of 1 Gaju, staked when you confirm the booking and kept if you then fail to deliver. Your payouts carry no fee. The contract never takes more than 10% of the shipping cost, even for a tiny shipment, and the rate is fixed when the quote is requested.</a:t>
             </a:r>
           </a:p>
         </p:txBody>
@@ -1001,7 +1001,7 @@
           <a:lstStyle/>
           <a:p>
             <a:r>
-              <a:t>Gajumaru is a public blockchain. The contracts are small, open source and will be externally audited before any real money flows.</a:t>
+              <a:t>Gajumaru is a public blockchain. The contracts are small, open source and will be externally audited before any real money flows. Forwarders and carriers are verified businesses: anyone can check the badge, and a company proves who it is to the customers it chooses, without its name going on the public ledger.</a:t>
             </a:r>
           </a:p>
         </p:txBody>
@@ -1141,7 +1141,7 @@
           <a:lstStyle/>
           <a:p>
             <a:r>
-              <a:t>Network fees are about 0.0002 Gaju per action, so a whole shipment with two legs costs about 0.0044 Gaju in network fees, shared between the parties. Prices and payments are in Gaju (木) for now; other currencies are out of scope for the pilot. The fee starts at 1% with a 1 Gaju minimum; both are set by GajuFreight's admin vote and can change, but a shipment keeps the settings in force when its quotes were requested. The 10% limit is fixed in the contract: no vote can raise the rate above it, and it overrides the minimum.</a:t>
+              <a:t>Network fees are about 0.0002 Gaju per action, so a whole shipment with two legs costs about 0.005 Gaju in network fees, shared between the parties. Prices and payments are in Gaju (木) for now; other currencies are out of scope for the pilot. The fee starts at 1% with a 1 Gaju minimum; both are set by GajuFreight's admin vote and can change, but a shipment keeps the settings in force when its quotes were requested. The 10% limit is fixed in the contract: no vote can raise the rate above it, and it overrides the minimum.</a:t>
             </a:r>
           </a:p>
         </p:txBody>
@@ -6592,7 +6592,7 @@
                 <a:gridCol w="3931920"/>
                 <a:gridCol w="4602175"/>
               </a:tblGrid>
-              <a:tr h="548640">
+              <a:tr h="480060">
                 <a:tc>
                   <a:txBody>
                     <a:bodyPr/>
@@ -6660,7 +6660,7 @@
                   </a:tcPr>
                 </a:tc>
               </a:tr>
-              <a:tr h="548640">
+              <a:tr h="480060">
                 <a:tc>
                   <a:txBody>
                     <a:bodyPr/>
@@ -6728,7 +6728,7 @@
                   </a:tcPr>
                 </a:tc>
               </a:tr>
-              <a:tr h="548640">
+              <a:tr h="480060">
                 <a:tc>
                   <a:txBody>
                     <a:bodyPr/>
@@ -6796,7 +6796,7 @@
                   </a:tcPr>
                 </a:tc>
               </a:tr>
-              <a:tr h="548640">
+              <a:tr h="480060">
                 <a:tc>
                   <a:txBody>
                     <a:bodyPr/>
@@ -6864,7 +6864,7 @@
                   </a:tcPr>
                 </a:tc>
               </a:tr>
-              <a:tr h="548640">
+              <a:tr h="480060">
                 <a:tc>
                   <a:txBody>
                     <a:bodyPr/>
@@ -6932,7 +6932,7 @@
                   </a:tcPr>
                 </a:tc>
               </a:tr>
-              <a:tr h="548640">
+              <a:tr h="480060">
                 <a:tc>
                   <a:txBody>
                     <a:bodyPr/>
@@ -7000,7 +7000,75 @@
                   </a:tcPr>
                 </a:tc>
               </a:tr>
-              <a:tr h="548640">
+              <a:tr h="480060">
+                <a:tc>
+                  <a:txBody>
+                    <a:bodyPr/>
+                    <a:lstStyle/>
+                    <a:p>
+                      <a:r>
+                        <a:rPr sz="1200" b="1">
+                          <a:solidFill>
+                            <a:srgbClr val="111827"/>
+                          </a:solidFill>
+                          <a:latin typeface="Montserrat"/>
+                        </a:rPr>
+                        <a:t>Who you're dealing with</a:t>
+                      </a:r>
+                    </a:p>
+                  </a:txBody>
+                  <a:tcPr anchor="ctr">
+                    <a:solidFill>
+                      <a:srgbClr val="FFFFFF"/>
+                    </a:solidFill>
+                  </a:tcPr>
+                </a:tc>
+                <a:tc>
+                  <a:txBody>
+                    <a:bodyPr/>
+                    <a:lstStyle/>
+                    <a:p>
+                      <a:r>
+                        <a:rPr sz="1200" b="0">
+                          <a:solidFill>
+                            <a:srgbClr val="4B5563"/>
+                          </a:solidFill>
+                          <a:latin typeface="Montserrat"/>
+                        </a:rPr>
+                        <a:t>A website and a letterhead</a:t>
+                      </a:r>
+                    </a:p>
+                  </a:txBody>
+                  <a:tcPr anchor="ctr">
+                    <a:solidFill>
+                      <a:srgbClr val="FFFFFF"/>
+                    </a:solidFill>
+                  </a:tcPr>
+                </a:tc>
+                <a:tc>
+                  <a:txBody>
+                    <a:bodyPr/>
+                    <a:lstStyle/>
+                    <a:p>
+                      <a:r>
+                        <a:rPr sz="1200" b="0">
+                          <a:solidFill>
+                            <a:srgbClr val="111827"/>
+                          </a:solidFill>
+                          <a:latin typeface="Montserrat"/>
+                        </a:rPr>
+                        <a:t>Verified businesses, with a badge anyone can check</a:t>
+                      </a:r>
+                    </a:p>
+                  </a:txBody>
+                  <a:tcPr anchor="ctr">
+                    <a:solidFill>
+                      <a:srgbClr val="FFF1EB"/>
+                    </a:solidFill>
+                  </a:tcPr>
+                </a:tc>
+              </a:tr>
+              <a:tr h="480060">
                 <a:tc>
                   <a:txBody>
                     <a:bodyPr/>
@@ -8083,7 +8151,7 @@
                 </a:solidFill>
                 <a:latin typeface="Montserrat"/>
               </a:rPr>
-              <a:t>The shipper funds the escrow when they book, so you never carry the credit risk.</a:t>
+              <a:t>The shipper funds the escrow when they book; you confirm before you move a box, so you never carry the credit risk.</a:t>
             </a:r>
           </a:p>
         </p:txBody>
@@ -9516,6 +9584,22 @@
               <a:t>Platform fees paid</a:t>
             </a:r>
           </a:p>
+          <a:p>
+            <a:pPr algn="l">
+              <a:spcAft>
+                <a:spcPts val="560"/>
+              </a:spcAft>
+            </a:pPr>
+            <a:r>
+              <a:rPr sz="1400" b="0">
+                <a:solidFill>
+                  <a:srgbClr val="111827"/>
+                </a:solidFill>
+                <a:latin typeface="Montserrat"/>
+              </a:rPr>
+              <a:t>Which addresses are verified businesses (no names)</a:t>
+            </a:r>
+          </a:p>
         </p:txBody>
       </p:sp>
       <p:sp>
@@ -10130,7 +10214,7 @@
                 </a:solidFill>
                 <a:latin typeface="Montserrat"/>
               </a:rPr>
-              <a:t>1% of the shipping cost (minimum 1 Gaju), fixed when the quote is requested. Never more than 10%: a limit built into the contract.</a:t>
+              <a:t>1% of the shipping cost (minimum 1 Gaju), staked when you confirm the booking and kept if you fail to deliver. Never more than 10%: a limit built into the contract.</a:t>
             </a:r>
           </a:p>
         </p:txBody>

</xml_diff>

<commit_message>
docs(pitch): describe the fee as paid on confirming, not a deposit
Independent review of the deck update on #158: "staked and kept if you
fail to deliver" read like a refundable deposit, but the fee is kept
however the shipment ends; the deck now says it is paid when the
forwarder confirms. Verification is a badge verified businesses carry,
not a guarantee every party is verified. The 10% limit and fee terms
live on the pricing slide only. The booking note keeps the shipper's
right to cancel, and the leg journey shows funding before confirm.
</commit_message>
<xml_diff>
--- a/docs/pitch/gajufreight-pitch-deck.pptx
+++ b/docs/pitch/gajufreight-pitch-deck.pptx
@@ -931,7 +931,7 @@
           <a:lstStyle/>
           <a:p>
             <a:r>
-              <a:t>Fee: 1% of the shipping cost, with a minimum of 1 Gaju, staked when you confirm the booking and kept if you then fail to deliver. Your payouts carry no fee. The contract never takes more than 10% of the shipping cost, even for a tiny shipment, and the rate is fixed when the quote is requested.</a:t>
+              <a:t>You pay GajuFreight's fee once, when you confirm the booking, and your payouts carry no fee: see Pricing.</a:t>
             </a:r>
           </a:p>
         </p:txBody>
@@ -1001,7 +1001,7 @@
           <a:lstStyle/>
           <a:p>
             <a:r>
-              <a:t>Gajumaru is a public blockchain. The contracts are small, open source and will be externally audited before any real money flows. Forwarders and carriers are verified businesses: anyone can check the badge, and a company proves who it is to the customers it chooses, without its name going on the public ledger.</a:t>
+              <a:t>Gajumaru is a public blockchain. The contracts are small, open source and will be externally audited before any real money flows. Verified businesses carry a badge anyone can check, and a company proves who it is to the customers it chooses, without its name going on the public ledger.</a:t>
             </a:r>
           </a:p>
         </p:txBody>
@@ -7057,7 +7057,7 @@
                           </a:solidFill>
                           <a:latin typeface="Montserrat"/>
                         </a:rPr>
-                        <a:t>Verified businesses, with a badge anyone can check</a:t>
+                        <a:t>A verification badge anyone can check</a:t>
                       </a:r>
                     </a:p>
                   </a:txBody>
@@ -7826,7 +7826,7 @@
                 </a:solidFill>
                 <a:latin typeface="Montserrat"/>
               </a:rPr>
-              <a:t>Invited forwarders quote on the same consignment; you pay the price you accepted and no platform fee.</a:t>
+              <a:t>Invited forwarders quote on the same consignment; you pay exactly the price you accepted.</a:t>
             </a:r>
           </a:p>
         </p:txBody>
@@ -8151,7 +8151,7 @@
                 </a:solidFill>
                 <a:latin typeface="Montserrat"/>
               </a:rPr>
-              <a:t>The shipper funds the escrow when they book; you confirm before you move a box, so you never carry the credit risk.</a:t>
+              <a:t>The shipper funds the escrow when they book, so you see the money before you confirm and never carry the credit risk.</a:t>
             </a:r>
           </a:p>
         </p:txBody>
@@ -10214,7 +10214,7 @@
                 </a:solidFill>
                 <a:latin typeface="Montserrat"/>
               </a:rPr>
-              <a:t>1% of the shipping cost (minimum 1 Gaju), staked when you confirm the booking and kept if you fail to deliver. Never more than 10%: a limit built into the contract.</a:t>
+              <a:t>1% of the shipping cost (minimum 1 Gaju), paid when you confirm the booking, however the shipment ends. Payouts carry no fee. Never more than 10%: a limit built into the contract.</a:t>
             </a:r>
           </a:p>
         </p:txBody>

</xml_diff>

<commit_message>
docs: align older docs and the deck with ADR 0018 and 0019
A sweep after #156-#158 merged found older docs still describing the
leg fee bond or a booking that ends at funding. ADR 0004 and 0005 get
dated supersession notes rather than rewrites; the blueprint scope,
HLD stage diagram and wireframes index mention the forwarder's
confirmation; and the deck's "How it works" step shows it too.
</commit_message>
<xml_diff>
--- a/docs/pitch/gajufreight-pitch-deck.pptx
+++ b/docs/pitch/gajufreight-pitch-deck.pptx
@@ -6078,7 +6078,7 @@
                 </a:solidFill>
                 <a:latin typeface="Montserrat"/>
               </a:rPr>
-              <a:t>2  Fund</a:t>
+              <a:t>2  Fund and confirm</a:t>
             </a:r>
           </a:p>
         </p:txBody>
@@ -6117,7 +6117,7 @@
                 </a:solidFill>
                 <a:latin typeface="Montserrat"/>
               </a:rPr>
-              <a:t>One signature locks the agreed price in an escrow contract, on exactly the agreed terms.</a:t>
+              <a:t>One signature locks the agreed price in escrow. The forwarder confirms, paying the fee; until then the shipper can cancel.</a:t>
             </a:r>
           </a:p>
         </p:txBody>

</xml_diff>

<commit_message>
docs: record extra charges, event milestones and Incoterms
ADR 0020 sets the design the contracts now implement. The invariants
cover charges passing straight through; the HLD gains rule 12, event
labels in rule 8, the Incoterm in §6.8 and §9.2, a §9.8 sequence for
charges and the new entrypoints in §3; the threat model adds T31 and
T32; the cost model counts charge calls; the contract skill's path
list includes charges; and the deck mentions Incoterms and extras.
</commit_message>
<xml_diff>
--- a/docs/pitch/gajufreight-pitch-deck.pptx
+++ b/docs/pitch/gajufreight-pitch-deck.pptx
@@ -5995,7 +5995,7 @@
                 </a:solidFill>
                 <a:latin typeface="Montserrat"/>
               </a:rPr>
-              <a:t>The shipper invites forwarders to quote. Up to three counter offers, then the shipper accepts. The terms are fixed.</a:t>
+              <a:t>The shipper invites forwarders to quote on a stated Incoterm. Up to three counter offers, then the shipper accepts. Terms are fixed.</a:t>
             </a:r>
           </a:p>
         </p:txBody>
@@ -6592,7 +6592,7 @@
                 <a:gridCol w="3931920"/>
                 <a:gridCol w="4602175"/>
               </a:tblGrid>
-              <a:tr h="480060">
+              <a:tr h="426720">
                 <a:tc>
                   <a:txBody>
                     <a:bodyPr/>
@@ -6660,7 +6660,7 @@
                   </a:tcPr>
                 </a:tc>
               </a:tr>
-              <a:tr h="480060">
+              <a:tr h="426720">
                 <a:tc>
                   <a:txBody>
                     <a:bodyPr/>
@@ -6728,7 +6728,7 @@
                   </a:tcPr>
                 </a:tc>
               </a:tr>
-              <a:tr h="480060">
+              <a:tr h="426720">
                 <a:tc>
                   <a:txBody>
                     <a:bodyPr/>
@@ -6796,7 +6796,7 @@
                   </a:tcPr>
                 </a:tc>
               </a:tr>
-              <a:tr h="480060">
+              <a:tr h="426720">
                 <a:tc>
                   <a:txBody>
                     <a:bodyPr/>
@@ -6864,7 +6864,7 @@
                   </a:tcPr>
                 </a:tc>
               </a:tr>
-              <a:tr h="480060">
+              <a:tr h="426720">
                 <a:tc>
                   <a:txBody>
                     <a:bodyPr/>
@@ -6932,7 +6932,7 @@
                   </a:tcPr>
                 </a:tc>
               </a:tr>
-              <a:tr h="480060">
+              <a:tr h="426720">
                 <a:tc>
                   <a:txBody>
                     <a:bodyPr/>
@@ -7000,7 +7000,75 @@
                   </a:tcPr>
                 </a:tc>
               </a:tr>
-              <a:tr h="480060">
+              <a:tr h="426720">
+                <a:tc>
+                  <a:txBody>
+                    <a:bodyPr/>
+                    <a:lstStyle/>
+                    <a:p>
+                      <a:r>
+                        <a:rPr sz="1200" b="1">
+                          <a:solidFill>
+                            <a:srgbClr val="111827"/>
+                          </a:solidFill>
+                          <a:latin typeface="Montserrat"/>
+                        </a:rPr>
+                        <a:t>Extra charges (storage, waiting, duties)</a:t>
+                      </a:r>
+                    </a:p>
+                  </a:txBody>
+                  <a:tcPr anchor="ctr">
+                    <a:solidFill>
+                      <a:srgbClr val="FFFFFF"/>
+                    </a:solidFill>
+                  </a:tcPr>
+                </a:tc>
+                <a:tc>
+                  <a:txBody>
+                    <a:bodyPr/>
+                    <a:lstStyle/>
+                    <a:p>
+                      <a:r>
+                        <a:rPr sz="1200" b="0">
+                          <a:solidFill>
+                            <a:srgbClr val="4B5563"/>
+                          </a:solidFill>
+                          <a:latin typeface="Montserrat"/>
+                        </a:rPr>
+                        <a:t>Separate invoices, chased for weeks</a:t>
+                      </a:r>
+                    </a:p>
+                  </a:txBody>
+                  <a:tcPr anchor="ctr">
+                    <a:solidFill>
+                      <a:srgbClr val="FFFFFF"/>
+                    </a:solidFill>
+                  </a:tcPr>
+                </a:tc>
+                <a:tc>
+                  <a:txBody>
+                    <a:bodyPr/>
+                    <a:lstStyle/>
+                    <a:p>
+                      <a:r>
+                        <a:rPr sz="1200" b="0">
+                          <a:solidFill>
+                            <a:srgbClr val="111827"/>
+                          </a:solidFill>
+                          <a:latin typeface="Montserrat"/>
+                        </a:rPr>
+                        <a:t>Proposed with evidence, paid straight through on acceptance</a:t>
+                      </a:r>
+                    </a:p>
+                  </a:txBody>
+                  <a:tcPr anchor="ctr">
+                    <a:solidFill>
+                      <a:srgbClr val="FFF1EB"/>
+                    </a:solidFill>
+                  </a:tcPr>
+                </a:tc>
+              </a:tr>
+              <a:tr h="426720">
                 <a:tc>
                   <a:txBody>
                     <a:bodyPr/>
@@ -7068,7 +7136,7 @@
                   </a:tcPr>
                 </a:tc>
               </a:tr>
-              <a:tr h="480060">
+              <a:tr h="426720">
                 <a:tc>
                   <a:txBody>
                     <a:bodyPr/>
@@ -10214,7 +10282,7 @@
                 </a:solidFill>
                 <a:latin typeface="Montserrat"/>
               </a:rPr>
-              <a:t>1% of the shipping cost (minimum 1 Gaju), paid when you confirm the booking, however the shipment ends. Payouts carry no fee. Never more than 10%: a limit built into the contract.</a:t>
+              <a:t>1% of the shipping cost (minimum 1 Gaju), paid when you confirm the booking, however the shipment ends. Payouts and extra charges carry no fee. Never more than 10%, by contract.</a:t>
             </a:r>
           </a:p>
         </p:txBody>

</xml_diff>

<commit_message>
docs(ux): extra charges, Incoterms and fair arbitration in the UX
Screens and journeys follow ADR 0020 and ADR 0022. Shippers pick an
Incoterm and a panel of verified arbiters; forwarders can swap one
arbiter or decline over the panel, and quote event milestones. The
forwarder proposes extra charges with evidence and the shipper
accepts (paid straight through, no fee) or declines. Disputes are
raised with a deposit; the consignee reports through the delivery
company, which flags it, and never pays or signs; arbiters see their
fee, paid whichever way they vote. Admin settings gain the arbiter
fee, the flag window and verified roles; the deck follows.
</commit_message>
<xml_diff>
--- a/docs/pitch/gajufreight-pitch-deck.pptx
+++ b/docs/pitch/gajufreight-pitch-deck.pptx
@@ -1001,7 +1001,7 @@
           <a:lstStyle/>
           <a:p>
             <a:r>
-              <a:t>Gajumaru is a public blockchain. The contracts are small, open source and will be externally audited before any real money flows. Verified businesses carry a badge anyone can check, and a company proves who it is to the customers it chooses, without its name going on the public ledger.</a:t>
+              <a:t>Gajumaru is a public blockchain. The contracts are small, open source and will be externally audited before any real money flows. Verified businesses carry a badge anyone can check, and a company proves who it is to the customers it chooses, without its name going on the public ledger. Disputes go to verified, independent arbiters paid the same whichever way they rule; the raiser stakes a small deposit, and the consignee never pays to report a problem.</a:t>
             </a:r>
           </a:p>
         </p:txBody>
@@ -6361,7 +6361,7 @@
                 </a:solidFill>
                 <a:latin typeface="Montserrat"/>
               </a:rPr>
-              <a:t>Proven delivery releases the rest. Missed deadline: the shipper is refunded. Dispute: a panel decides.</a:t>
+              <a:t>Proven delivery releases the rest. Missed deadline: the shipper is refunded. Dispute: verified arbiters decide.</a:t>
             </a:r>
           </a:p>
         </p:txBody>
@@ -6989,7 +6989,7 @@
                           </a:solidFill>
                           <a:latin typeface="Montserrat"/>
                         </a:rPr>
-                        <a:t>Panel of arbiters, with a fallback split agreed up front</a:t>
+                        <a:t>Verified arbiters, paid whichever way they rule; fallback agreed</a:t>
                       </a:r>
                     </a:p>
                   </a:txBody>

</xml_diff>